<commit_message>
Update STB mobile report with CEO-guided 2Q26 preliminary figures
- STB mobile report (EN + VN): results block now carries CEO Loic
  Faussier's press guidance — 2Q26 PBT VND1,900-2,000bn (~-50% YoY),
  NPL est. ~5.6%, record provisioning >VND4.7tn; section titles and
  cover dates refreshed to 24.07.2026. AGM targets, forecast block,
  charts, rating, and TP unchanged (official BCTC pending).
- Main deck: STB attribution sharpened to cite the CEO interview.

Co-Authored-By: Claude Fable 5 <noreply@anthropic.com>
Claude-Session: https://claude.ai/code/session_01QPsxWfyBSmSQjUzo5EDnm5
</commit_message>
<xml_diff>
--- a/MASVN_RS_WM_2H26_outlook_Equity_VN_2026_STBEIB_2Q26update_24July2026.pptx
+++ b/MASVN_RS_WM_2H26_outlook_Equity_VN_2026_STBEIB_2Q26update_24July2026.pptx
@@ -11796,7 +11796,7 @@
                 <a:ea typeface="Noto Sans" panose="020B0502040504020204" pitchFamily="34" charset="0"/>
                 <a:cs typeface="Noto Sans" panose="020B0502040504020204" pitchFamily="34" charset="0"/>
               </a:rPr>
-              <a:t>Official 2Q26 financial statements are pending — figures reflect management guidance and broker previews (consensus 2Q26 NPAT: ~VND 1,666bn, -42% YoY). The decline is driven by continued NIM compression amid intense deposit competition, and by stepped-up resolution of legacy assets: 2Q26 provisioning is estimated above VND 4,700bn — a record quarterly high and among the highest in the sector — after VND 2,024bn in 1Q26. The NPL ratio is estimated at ~5.6% at end-2Q26 (from 6.62% at end-1Q26) as write-offs and collateral resolution accelerate, though still above the sub-4.5% FY26 target. Recall 1Q26: PBT VND 2,106bn (-42.7% YoY), NII VND 6,042bn (-12.0% YoY), CASA 15.9%, CIR 45.2%.</a:t>
+              <a:t>Official 2Q26 financial statements are pending — figures reflect CEO Loic Faussier's guidance to press and broker previews (consensus 2Q26 NPAT: ~VND 1,666bn, -42% YoY). The decline is driven by continued NIM compression amid intense deposit competition, and by stepped-up resolution of legacy assets: 2Q26 provisioning is estimated above VND 4,700bn — a record quarterly high and among the highest in the sector — after VND 2,024bn in 1Q26. The NPL ratio is estimated at ~5.6% at end-2Q26 (from 6.62% at end-1Q26) as write-offs and collateral resolution accelerate, though still above the sub-4.5% FY26 target. Recall 1Q26: PBT VND 2,106bn (-42.7% YoY), NII VND 6,042bn (-12.0% YoY), CASA 15.9%, CIR 45.2%.</a:t>
             </a:r>
           </a:p>
           <a:p>
@@ -20503,7 +20503,7 @@
                 <a:ea typeface="Noto Sans" panose="020B0502040504020204" pitchFamily="34" charset="0"/>
                 <a:cs typeface="Noto Sans" panose="020B0502040504020204" pitchFamily="34" charset="0"/>
               </a:rPr>
-              <a:t>LNTT Q2/2026 ước đạt ~1,900–2,000 tỷ đồng (≈-50% CK), đưa LNTT 1H26 lên ~4,000–4,100 tỷ đồng (-45% CK; ~50% kế hoạch năm 8,100 tỷ đồng). BCTC chính thức Q2/2026 chưa công bố — số liệu phản ánh ước tính của ngân hàng và dự phóng của các CTCK (LNST Q2/2026 đồng thuận ~1,666 tỷ đồng, -42% CK). Nguyên nhân chính là NIM tiếp tục chịu áp lực trong bối cảnh cạnh tranh huy động gay gắt, cùng việc đẩy mạnh xử lý tài sản tồn đọng: chi phí dự phòng Q2/2026 ước vượt 4,700 tỷ đồng — mức cao kỷ lục theo quý và thuộc nhóm cao nhất ngành — sau mức 2,024 tỷ đồng trong Q1/2026.</a:t>
+              <a:t>LNTT Q2/2026 ước đạt ~1,900–2,000 tỷ đồng (≈-50% CK), đưa LNTT 1H26 lên ~4,000–4,100 tỷ đồng (-45% CK; ~50% kế hoạch năm 8,100 tỷ đồng). BCTC chính thức Q2/2026 chưa công bố — số liệu theo chia sẻ của Tổng giám đốc Loic Faussier với báo chí và dự phóng của các CTCK (LNST Q2/2026 đồng thuận ~1,666 tỷ đồng, -42% CK). Nguyên nhân chính là NIM tiếp tục chịu áp lực trong bối cảnh cạnh tranh huy động gay gắt, cùng việc đẩy mạnh xử lý tài sản tồn đọng: chi phí dự phòng Q2/2026 ước vượt 4,700 tỷ đồng — mức cao kỷ lục theo quý và thuộc nhóm cao nhất ngành — sau mức 2,024 tỷ đồng trong Q1/2026.</a:t>
             </a:r>
           </a:p>
           <a:p>

</xml_diff>

<commit_message>
Plain-language rewrite; remove competitor references; cut VRE text ~20%
1) Jargon removed across the FPT and VRE narrative cells: "property leg
   haircut", "annualise", "lease-up", "optionality", "base-case engine",
   "step-up", "lumpy", "150bp of margin dilution", "flattered",
   "underpins", "insulated from", "GM". Replaced with plain wording.
2) All references to other securities firms removed from the
   client-facing stock pick and the STB/EIB deck; the internal
   provenance file now cites "a competing broker" without naming it.
3) VRE Growth cell cut a further ~18% (1,324 -> 1,089 chars).
4) Fixed a stale figure in the VRE valuation cell: P/B and BVPS now show
   the restated 1.30x / ~VND21,600 rather than the superseded
   1.23x / ~VND22,800.

Co-Authored-By: Claude Fable 5 <noreply@anthropic.com>
Claude-Session: https://claude.ai/code/session_01QPsxWfyBSmSQjUzo5EDnm5
</commit_message>
<xml_diff>
--- a/MASVN_RS_WM_2H26_outlook_Equity_VN_2026_STBEIB_2Q26update_24July2026.pptx
+++ b/MASVN_RS_WM_2H26_outlook_Equity_VN_2026_STBEIB_2Q26update_24July2026.pptx
@@ -29681,7 +29681,7 @@
                 <a:ea typeface="Noto Sans" panose="020B0502040504020204" pitchFamily="34" charset="0"/>
                 <a:cs typeface="Noto Sans" panose="020B0502040504020204" pitchFamily="34" charset="0"/>
               </a:rPr>
-              <a:t>1H26 PBT reached VND 730bn (-51% YoY vs VND 1,488bn in 1H25), fulfilling 41% of the annual plan per management — implying 2Q26 PBT of ~VND 392bn (+16% QoQ; -41% YoY), in line with broker previews (MBS: VND 387bn). At end-2Q26, total assets stood at VND 266.5tn (down ~VND 6tn YTD), customer funding at VND 192.6tn, and loans above VND 200tn. The NPL ratio improved to 2.88% (from 3.07% at end-1Q26), back below the 3% threshold and tracking toward the sub-2.5% year-end target. Liquidity and capital remain comfortable: CAR at 12.5% (vs the 8% minimum), 30-day liquidity ratio above 80%, and LDR ~83% (below the 85% cap). Detailed 2Q26 financial statements are pending.</a:t>
+              <a:t>1H26 PBT reached VND 730bn (-51% YoY vs VND 1,488bn in 1H25), fulfilling 41% of the annual plan per management — implying 2Q26 PBT of ~VND 392bn (+16% QoQ; -41% YoY), in line with broker previews (broker consensus). At end-2Q26, total assets stood at VND 266.5tn (down ~VND 6tn YTD), customer funding at VND 192.6tn, and loans above VND 200tn. The NPL ratio improved to 2.88% (from 3.07% at end-1Q26), back below the 3% threshold and tracking toward the sub-2.5% year-end target. Liquidity and capital remain comfortable: CAR at 12.5% (vs the 8% minimum), 30-day liquidity ratio above 80%, and LDR ~83% (below the 85% cap). Detailed 2Q26 financial statements are pending.</a:t>
             </a:r>
             <a:endParaRPr kumimoji="1" lang="en-US" altLang="ko-KR" sz="800" b="1" dirty="0">
               <a:solidFill>
@@ -38216,7 +38216,7 @@
                 <a:ea typeface="Noto Sans" panose="020B0502040504020204" pitchFamily="34" charset="0"/>
                 <a:cs typeface="Noto Sans" panose="020B0502040504020204" pitchFamily="34" charset="0"/>
               </a:rPr>
-              <a:t>LNTT 1H26 đạt 730 tỷ đồng (-51% CK so với 1,488 tỷ đồng 1H25), hoàn thành 41% kế hoạch năm theo ban lãnh đạo — tương ứng LNTT Q2/2026 ~392 tỷ đồng (+16% QoQ; -41% CK), sát dự báo của các CTCK (MBS: 387 tỷ đồng). Cuối Q2/2026, tổng tài sản đạt 266.5 nghìn tỷ đồng (giảm ~6 nghìn tỷ YTD), vốn huy động 192.6 nghìn tỷ đồng, dư nợ cho vay trên 200 nghìn tỷ đồng. Tỷ lệ NPL cải thiện về 2.88% (từ 3.07% cuối Q1/2026), trở lại dưới ngưỡng 3% và bám sát mục tiêu dưới 2.5% cuối năm. Thanh khoản và vốn ở mức an toàn: CAR 12.5% (quy định tối thiểu 8%), tỷ lệ khả năng chi trả 30 ngày trên 80%, LDR ~83% (dưới trần 85%). BCTC chi tiết Q2/2026 chưa công bố.</a:t>
+              <a:t>LNTT 1H26 đạt 730 tỷ đồng (-51% CK so với 1,488 tỷ đồng 1H25), hoàn thành 41% kế hoạch năm theo ban lãnh đạo — tương ứng LNTT Q2/2026 ~392 tỷ đồng (+16% QoQ; -41% CK), sát dự báo của các CTCK (broker consensus). Cuối Q2/2026, tổng tài sản đạt 266.5 nghìn tỷ đồng (giảm ~6 nghìn tỷ YTD), vốn huy động 192.6 nghìn tỷ đồng, dư nợ cho vay trên 200 nghìn tỷ đồng. Tỷ lệ NPL cải thiện về 2.88% (từ 3.07% cuối Q1/2026), trở lại dưới ngưỡng 3% và bám sát mục tiêu dưới 2.5% cuối năm. Thanh khoản và vốn ở mức an toàn: CAR 12.5% (quy định tối thiểu 8%), tỷ lệ khả năng chi trả 30 ngày trên 80%, LDR ~83% (dưới trần 85%). BCTC chi tiết Q2/2026 chưa công bố.</a:t>
             </a:r>
           </a:p>
           <a:p>

</xml_diff>